<commit_message>
Added one line in presentation
</commit_message>
<xml_diff>
--- a/index.pptx
+++ b/index.pptx
@@ -126,6 +126,46 @@
 
 <file path=ppt/changesInfos/changesInfo1.xml><?xml version="1.0" encoding="utf-8"?>
 <pc:chgInfo xmlns:a="http://schemas.openxmlformats.org/drawingml/2006/main" xmlns:r="http://schemas.openxmlformats.org/officeDocument/2006/relationships" xmlns:ac="http://schemas.microsoft.com/office/drawing/2013/main/command" xmlns:pc="http://schemas.microsoft.com/office/powerpoint/2013/main/command">
+  <pc:docChgLst>
+    <pc:chgData name="Muhammad Shehzad" userId="bfd9d5219f1f2561" providerId="LiveId" clId="{8B332B6E-F8FE-40E8-B545-E0BA259A5827}"/>
+    <pc:docChg chg="modSld">
+      <pc:chgData name="Muhammad Shehzad" userId="bfd9d5219f1f2561" providerId="LiveId" clId="{8B332B6E-F8FE-40E8-B545-E0BA259A5827}" dt="2026-08-31T16:44:12.297" v="42" actId="1076"/>
+      <pc:docMkLst>
+        <pc:docMk/>
+      </pc:docMkLst>
+      <pc:sldChg chg="addSp modSp mod">
+        <pc:chgData name="Muhammad Shehzad" userId="bfd9d5219f1f2561" providerId="LiveId" clId="{8B332B6E-F8FE-40E8-B545-E0BA259A5827}" dt="2026-08-31T16:44:12.297" v="42" actId="1076"/>
+        <pc:sldMkLst>
+          <pc:docMk/>
+          <pc:sldMk cId="3787414942" sldId="258"/>
+        </pc:sldMkLst>
+        <pc:spChg chg="add mod">
+          <ac:chgData name="Muhammad Shehzad" userId="bfd9d5219f1f2561" providerId="LiveId" clId="{8B332B6E-F8FE-40E8-B545-E0BA259A5827}" dt="2026-08-31T16:43:57.137" v="41" actId="1076"/>
+          <ac:spMkLst>
+            <pc:docMk/>
+            <pc:sldMk cId="3787414942" sldId="258"/>
+            <ac:spMk id="5" creationId="{808C7CB0-42C6-4BA8-850F-16DFE381B073}"/>
+          </ac:spMkLst>
+        </pc:spChg>
+        <pc:spChg chg="mod">
+          <ac:chgData name="Muhammad Shehzad" userId="bfd9d5219f1f2561" providerId="LiveId" clId="{8B332B6E-F8FE-40E8-B545-E0BA259A5827}" dt="2026-08-31T16:44:12.297" v="42" actId="1076"/>
+          <ac:spMkLst>
+            <pc:docMk/>
+            <pc:sldMk cId="3787414942" sldId="258"/>
+            <ac:spMk id="7" creationId="{25F3C39E-565E-4D71-886C-97C93D0CF00A}"/>
+          </ac:spMkLst>
+        </pc:spChg>
+        <pc:spChg chg="mod">
+          <ac:chgData name="Muhammad Shehzad" userId="bfd9d5219f1f2561" providerId="LiveId" clId="{8B332B6E-F8FE-40E8-B545-E0BA259A5827}" dt="2026-08-31T16:43:17.645" v="37" actId="1076"/>
+          <ac:spMkLst>
+            <pc:docMk/>
+            <pc:sldMk cId="3787414942" sldId="258"/>
+            <ac:spMk id="8" creationId="{84CF08AF-1849-473B-8582-07AF786417C6}"/>
+          </ac:spMkLst>
+        </pc:spChg>
+      </pc:sldChg>
+    </pc:docChg>
+  </pc:docChgLst>
   <pc:docChgLst>
     <pc:chgData name="Muhammad Shehzad" userId="bfd9d5219f1f2561" providerId="LiveId" clId="{FA069845-5433-4505-A336-9CEEC015FE4E}"/>
     <pc:docChg chg="addSld modSld">
@@ -1085,7 +1125,7 @@
           <a:p>
             <a:fld id="{03BA0086-0CD5-4F49-834E-2D5D0784A664}" type="datetimeFigureOut">
               <a:rPr lang="en-US" smtClean="0"/>
-              <a:t>8/30/2026</a:t>
+              <a:t>8/31/2026</a:t>
             </a:fld>
             <a:endParaRPr lang="en-US"/>
           </a:p>
@@ -1336,7 +1376,7 @@
           <a:p>
             <a:fld id="{03BA0086-0CD5-4F49-834E-2D5D0784A664}" type="datetimeFigureOut">
               <a:rPr lang="en-US" smtClean="0"/>
-              <a:t>8/30/2026</a:t>
+              <a:t>8/31/2026</a:t>
             </a:fld>
             <a:endParaRPr lang="en-US"/>
           </a:p>
@@ -1650,7 +1690,7 @@
           <a:p>
             <a:fld id="{03BA0086-0CD5-4F49-834E-2D5D0784A664}" type="datetimeFigureOut">
               <a:rPr lang="en-US" smtClean="0"/>
-              <a:t>8/30/2026</a:t>
+              <a:t>8/31/2026</a:t>
             </a:fld>
             <a:endParaRPr lang="en-US"/>
           </a:p>
@@ -1991,7 +2031,7 @@
           <a:p>
             <a:fld id="{03BA0086-0CD5-4F49-834E-2D5D0784A664}" type="datetimeFigureOut">
               <a:rPr lang="en-US" smtClean="0"/>
-              <a:t>8/30/2026</a:t>
+              <a:t>8/31/2026</a:t>
             </a:fld>
             <a:endParaRPr lang="en-US"/>
           </a:p>
@@ -2305,7 +2345,7 @@
           <a:p>
             <a:fld id="{03BA0086-0CD5-4F49-834E-2D5D0784A664}" type="datetimeFigureOut">
               <a:rPr lang="en-US" smtClean="0"/>
-              <a:t>8/30/2026</a:t>
+              <a:t>8/31/2026</a:t>
             </a:fld>
             <a:endParaRPr lang="en-US"/>
           </a:p>
@@ -2698,7 +2738,7 @@
           <a:p>
             <a:fld id="{03BA0086-0CD5-4F49-834E-2D5D0784A664}" type="datetimeFigureOut">
               <a:rPr lang="en-US" smtClean="0"/>
-              <a:t>8/30/2026</a:t>
+              <a:t>8/31/2026</a:t>
             </a:fld>
             <a:endParaRPr lang="en-US"/>
           </a:p>
@@ -2868,7 +2908,7 @@
           <a:p>
             <a:fld id="{03BA0086-0CD5-4F49-834E-2D5D0784A664}" type="datetimeFigureOut">
               <a:rPr lang="en-US" smtClean="0"/>
-              <a:t>8/30/2026</a:t>
+              <a:t>8/31/2026</a:t>
             </a:fld>
             <a:endParaRPr lang="en-US"/>
           </a:p>
@@ -3048,7 +3088,7 @@
           <a:p>
             <a:fld id="{03BA0086-0CD5-4F49-834E-2D5D0784A664}" type="datetimeFigureOut">
               <a:rPr lang="en-US" smtClean="0"/>
-              <a:t>8/30/2026</a:t>
+              <a:t>8/31/2026</a:t>
             </a:fld>
             <a:endParaRPr lang="en-US"/>
           </a:p>
@@ -3224,7 +3264,7 @@
           <a:p>
             <a:fld id="{03BA0086-0CD5-4F49-834E-2D5D0784A664}" type="datetimeFigureOut">
               <a:rPr lang="en-US" smtClean="0"/>
-              <a:t>8/30/2026</a:t>
+              <a:t>8/31/2026</a:t>
             </a:fld>
             <a:endParaRPr lang="en-US"/>
           </a:p>
@@ -3471,7 +3511,7 @@
           <a:p>
             <a:fld id="{03BA0086-0CD5-4F49-834E-2D5D0784A664}" type="datetimeFigureOut">
               <a:rPr lang="en-US" smtClean="0"/>
-              <a:t>8/30/2026</a:t>
+              <a:t>8/31/2026</a:t>
             </a:fld>
             <a:endParaRPr lang="en-US"/>
           </a:p>
@@ -3703,7 +3743,7 @@
           <a:p>
             <a:fld id="{03BA0086-0CD5-4F49-834E-2D5D0784A664}" type="datetimeFigureOut">
               <a:rPr lang="en-US" smtClean="0"/>
-              <a:t>8/30/2026</a:t>
+              <a:t>8/31/2026</a:t>
             </a:fld>
             <a:endParaRPr lang="en-US"/>
           </a:p>
@@ -4077,7 +4117,7 @@
           <a:p>
             <a:fld id="{03BA0086-0CD5-4F49-834E-2D5D0784A664}" type="datetimeFigureOut">
               <a:rPr lang="en-US" smtClean="0"/>
-              <a:t>8/30/2026</a:t>
+              <a:t>8/31/2026</a:t>
             </a:fld>
             <a:endParaRPr lang="en-US"/>
           </a:p>
@@ -4200,7 +4240,7 @@
           <a:p>
             <a:fld id="{03BA0086-0CD5-4F49-834E-2D5D0784A664}" type="datetimeFigureOut">
               <a:rPr lang="en-US" smtClean="0"/>
-              <a:t>8/30/2026</a:t>
+              <a:t>8/31/2026</a:t>
             </a:fld>
             <a:endParaRPr lang="en-US"/>
           </a:p>
@@ -4295,7 +4335,7 @@
           <a:p>
             <a:fld id="{03BA0086-0CD5-4F49-834E-2D5D0784A664}" type="datetimeFigureOut">
               <a:rPr lang="en-US" smtClean="0"/>
-              <a:t>8/30/2026</a:t>
+              <a:t>8/31/2026</a:t>
             </a:fld>
             <a:endParaRPr lang="en-US"/>
           </a:p>
@@ -4550,7 +4590,7 @@
           <a:p>
             <a:fld id="{03BA0086-0CD5-4F49-834E-2D5D0784A664}" type="datetimeFigureOut">
               <a:rPr lang="en-US" smtClean="0"/>
-              <a:t>8/30/2026</a:t>
+              <a:t>8/31/2026</a:t>
             </a:fld>
             <a:endParaRPr lang="en-US"/>
           </a:p>
@@ -4813,7 +4853,7 @@
           <a:p>
             <a:fld id="{03BA0086-0CD5-4F49-834E-2D5D0784A664}" type="datetimeFigureOut">
               <a:rPr lang="en-US" smtClean="0"/>
-              <a:t>8/30/2026</a:t>
+              <a:t>8/31/2026</a:t>
             </a:fld>
             <a:endParaRPr lang="en-US"/>
           </a:p>
@@ -5556,7 +5596,7 @@
           <a:p>
             <a:fld id="{03BA0086-0CD5-4F49-834E-2D5D0784A664}" type="datetimeFigureOut">
               <a:rPr lang="en-US" smtClean="0"/>
-              <a:t>8/30/2026</a:t>
+              <a:t>8/31/2026</a:t>
             </a:fld>
             <a:endParaRPr lang="en-US"/>
           </a:p>
@@ -12125,7 +12165,7 @@
         </p:nvSpPr>
         <p:spPr>
           <a:xfrm>
-            <a:off x="1005840" y="3228945"/>
+            <a:off x="1005840" y="3700115"/>
             <a:ext cx="2949012" cy="400110"/>
           </a:xfrm>
           <a:prstGeom prst="rect">
@@ -12164,7 +12204,7 @@
         </p:nvSpPr>
         <p:spPr>
           <a:xfrm>
-            <a:off x="1005840" y="3755874"/>
+            <a:off x="995975" y="4203819"/>
             <a:ext cx="6924041" cy="1477328"/>
           </a:xfrm>
           <a:prstGeom prst="rect">
@@ -12190,6 +12230,45 @@
             <a:r>
               <a:rPr lang="en-US" dirty="0"/>
               <a:t> mosquito. For a long time, Dengue Fever caused illness in many people, but its actual cause was unknown. It was thought that the dengue is caused by heat and normal fever.</a:t>
+            </a:r>
+          </a:p>
+        </p:txBody>
+      </p:sp>
+      <p:sp>
+        <p:nvSpPr>
+          <p:cNvPr id="5" name="TextBox 4">
+            <a:extLst>
+              <a:ext uri="{FF2B5EF4-FFF2-40B4-BE49-F238E27FC236}">
+                <a16:creationId xmlns:a16="http://schemas.microsoft.com/office/drawing/2014/main" id="{808C7CB0-42C6-4BA8-850F-16DFE381B073}"/>
+              </a:ext>
+            </a:extLst>
+          </p:cNvPr>
+          <p:cNvSpPr txBox="1"/>
+          <p:nvPr/>
+        </p:nvSpPr>
+        <p:spPr>
+          <a:xfrm>
+            <a:off x="995975" y="3196411"/>
+            <a:ext cx="3781805" cy="400110"/>
+          </a:xfrm>
+          <a:prstGeom prst="rect">
+            <a:avLst/>
+          </a:prstGeom>
+          <a:noFill/>
+        </p:spPr>
+        <p:txBody>
+          <a:bodyPr wrap="none" rtlCol="0">
+            <a:spAutoFit/>
+          </a:bodyPr>
+          <a:lstStyle/>
+          <a:p>
+            <a:r>
+              <a:rPr lang="en-US" sz="2000" dirty="0">
+                <a:solidFill>
+                  <a:srgbClr val="92D050"/>
+                </a:solidFill>
+              </a:rPr>
+              <a:t>1.2: Steps Of Biological Method</a:t>
             </a:r>
           </a:p>
         </p:txBody>

</xml_diff>